<commit_message>
- implement checkpointed 8-stage onboarding extraction with resumable runs - discover workbook roles and trace the valuation chain across supplied sources - add deterministic verification for periods, TTM windows, formulas, pasted values and fund reconciliation - add source fingerprints, run manifests and revisioned run/artifact naming - identify reusable mappings, source precedence, formula preservation and quarterly roll-forward changes - preserve discrepancies and unknowns for human review instead of silently resolving them - support same-session resume without requiring identical workbook re-uploads - keep company-specific facts out of reusable extractor logic - document remaining onboarding polish separately from the working build
</commit_message>
<xml_diff>
--- a/2.plan/2.progress_updates/XPV_Valuation_Automation_-_CEO_Briefing_v9.pptx
+++ b/2.plan/2.progress_updates/XPV_Valuation_Automation_-_CEO_Briefing_v9.pptx
@@ -143,7 +143,7 @@
   <pc:docChgLst>
     <pc:chgData name="Aria Druker" userId="4df1af69-80de-47bc-b057-d5185b09c5fc" providerId="ADAL" clId="{F3C205D8-FD4F-45E7-B3B5-44D147A799DB}"/>
     <pc:docChg chg="undo custSel modSld">
-      <pc:chgData name="Aria Druker" userId="4df1af69-80de-47bc-b057-d5185b09c5fc" providerId="ADAL" clId="{F3C205D8-FD4F-45E7-B3B5-44D147A799DB}" dt="2026-10-15T22:10:26.965" v="397" actId="14100"/>
+      <pc:chgData name="Aria Druker" userId="4df1af69-80de-47bc-b057-d5185b09c5fc" providerId="ADAL" clId="{F3C205D8-FD4F-45E7-B3B5-44D147A799DB}" dt="2026-10-16T13:58:16.237" v="488" actId="20577"/>
       <pc:docMkLst>
         <pc:docMk/>
       </pc:docMkLst>
@@ -161,6 +161,13 @@
             <ac:spMk id="3" creationId="{00000000-0000-0000-0000-000000000000}"/>
           </ac:spMkLst>
         </pc:spChg>
+      </pc:sldChg>
+      <pc:sldChg chg="modNotesTx">
+        <pc:chgData name="Aria Druker" userId="4df1af69-80de-47bc-b057-d5185b09c5fc" providerId="ADAL" clId="{F3C205D8-FD4F-45E7-B3B5-44D147A799DB}" dt="2026-10-16T13:58:16.237" v="488" actId="20577"/>
+        <pc:sldMkLst>
+          <pc:docMk/>
+          <pc:sldMk cId="0" sldId="258"/>
+        </pc:sldMkLst>
       </pc:sldChg>
       <pc:sldChg chg="delSp modSp mod modNotesTx">
         <pc:chgData name="Aria Druker" userId="4df1af69-80de-47bc-b057-d5185b09c5fc" providerId="ADAL" clId="{F3C205D8-FD4F-45E7-B3B5-44D147A799DB}" dt="2026-10-15T14:12:53.402" v="358" actId="20577"/>
@@ -1387,11 +1394,13 @@
           <a:lstStyle/>
           <a:p>
             <a:r>
+              <a:rPr dirty="0"/>
               <a:t>- Takeaway: AI starts at the fund value, traces back.</a:t>
             </a:r>
           </a:p>
           <a:p>
             <a:r>
+              <a:rPr dirty="0"/>
               <a:t>- Then confirms each link forward. Quarterly mode is planned.</a:t>
             </a:r>
           </a:p>
@@ -2116,18 +2125,33 @@
           <a:lstStyle/>
           <a:p>
             <a:r>
+              <a:rPr dirty="0"/>
               <a:t>- Takeaway: AI finds, code checks, the analyst approves once.</a:t>
             </a:r>
           </a:p>
           <a:p>
             <a:r>
+              <a:rPr dirty="0"/>
               <a:t>- Solid is built today. Dashed is still to build.</a:t>
             </a:r>
           </a:p>
           <a:p>
             <a:r>
+              <a:rPr dirty="0"/>
               <a:t>- Memory means each quarter only new things need review.</a:t>
             </a:r>
+            <a:endParaRPr lang="en-US" dirty="0"/>
+          </a:p>
+          <a:p>
+            <a:r>
+              <a:rPr lang="en-US" dirty="0"/>
+              <a:t>- 5 points of updates to cover in the financial &amp; strategic update for </a:t>
+            </a:r>
+            <a:r>
+              <a:rPr lang="en-US"/>
+              <a:t>LP report</a:t>
+            </a:r>
+            <a:endParaRPr dirty="0"/>
           </a:p>
         </p:txBody>
       </p:sp>
@@ -2794,7 +2818,7 @@
           </a:prstGeom>
           <a:extLst>
             <a:ext uri="{C572A759-6A51-4108-AA02-DFA0A04FC94B}">
-              <ma14:wrappingTextBoxFlag xmlns="" xmlns:ma14="http://schemas.microsoft.com/office/mac/drawingml/2011/main" val="0"/>
+              <ma14:wrappingTextBoxFlag xmlns:ma14="http://schemas.microsoft.com/office/mac/drawingml/2011/main" xmlns="" val="0"/>
             </a:ext>
           </a:extLst>
         </p:spPr>
@@ -2902,7 +2926,7 @@
           </a:prstGeom>
           <a:extLst>
             <a:ext uri="{C572A759-6A51-4108-AA02-DFA0A04FC94B}">
-              <ma14:wrappingTextBoxFlag xmlns="" xmlns:ma14="http://schemas.microsoft.com/office/mac/drawingml/2011/main" val="0"/>
+              <ma14:wrappingTextBoxFlag xmlns:ma14="http://schemas.microsoft.com/office/mac/drawingml/2011/main" xmlns="" val="0"/>
             </a:ext>
           </a:extLst>
         </p:spPr>
@@ -3751,7 +3775,7 @@
           </a:prstGeom>
           <a:extLst>
             <a:ext uri="{C572A759-6A51-4108-AA02-DFA0A04FC94B}">
-              <ma14:wrappingTextBoxFlag xmlns="" xmlns:ma14="http://schemas.microsoft.com/office/mac/drawingml/2011/main" val="0"/>
+              <ma14:wrappingTextBoxFlag xmlns:ma14="http://schemas.microsoft.com/office/mac/drawingml/2011/main" xmlns="" val="0"/>
             </a:ext>
           </a:extLst>
         </p:spPr>
@@ -4730,7 +4754,7 @@
           </a:prstGeom>
           <a:extLst>
             <a:ext uri="{C572A759-6A51-4108-AA02-DFA0A04FC94B}">
-              <ma14:wrappingTextBoxFlag xmlns="" xmlns:ma14="http://schemas.microsoft.com/office/mac/drawingml/2011/main" val="0"/>
+              <ma14:wrappingTextBoxFlag xmlns:ma14="http://schemas.microsoft.com/office/mac/drawingml/2011/main" xmlns="" val="0"/>
             </a:ext>
           </a:extLst>
         </p:spPr>
@@ -7313,7 +7337,7 @@
           </a:prstGeom>
           <a:extLst>
             <a:ext uri="{C572A759-6A51-4108-AA02-DFA0A04FC94B}">
-              <ma14:wrappingTextBoxFlag xmlns="" xmlns:ma14="http://schemas.microsoft.com/office/mac/drawingml/2011/main" val="0"/>
+              <ma14:wrappingTextBoxFlag xmlns:ma14="http://schemas.microsoft.com/office/mac/drawingml/2011/main" xmlns="" val="0"/>
             </a:ext>
           </a:extLst>
         </p:spPr>
@@ -8162,7 +8186,7 @@
           </a:prstGeom>
           <a:extLst>
             <a:ext uri="{C572A759-6A51-4108-AA02-DFA0A04FC94B}">
-              <ma14:wrappingTextBoxFlag xmlns="" xmlns:ma14="http://schemas.microsoft.com/office/mac/drawingml/2011/main" val="0"/>
+              <ma14:wrappingTextBoxFlag xmlns:ma14="http://schemas.microsoft.com/office/mac/drawingml/2011/main" xmlns="" val="0"/>
             </a:ext>
           </a:extLst>
         </p:spPr>
@@ -8758,7 +8782,7 @@
           </a:prstGeom>
           <a:extLst>
             <a:ext uri="{C572A759-6A51-4108-AA02-DFA0A04FC94B}">
-              <ma14:wrappingTextBoxFlag xmlns="" xmlns:ma14="http://schemas.microsoft.com/office/mac/drawingml/2011/main" val="0"/>
+              <ma14:wrappingTextBoxFlag xmlns:ma14="http://schemas.microsoft.com/office/mac/drawingml/2011/main" xmlns="" val="0"/>
             </a:ext>
           </a:extLst>
         </p:spPr>
@@ -10052,7 +10076,7 @@
           </a:prstGeom>
           <a:extLst>
             <a:ext uri="{C572A759-6A51-4108-AA02-DFA0A04FC94B}">
-              <ma14:wrappingTextBoxFlag xmlns="" xmlns:ma14="http://schemas.microsoft.com/office/mac/drawingml/2011/main" val="0"/>
+              <ma14:wrappingTextBoxFlag xmlns:ma14="http://schemas.microsoft.com/office/mac/drawingml/2011/main" xmlns="" val="0"/>
             </a:ext>
           </a:extLst>
         </p:spPr>
@@ -10660,7 +10684,7 @@
           </a:prstGeom>
           <a:extLst>
             <a:ext uri="{C572A759-6A51-4108-AA02-DFA0A04FC94B}">
-              <ma14:wrappingTextBoxFlag xmlns="" xmlns:ma14="http://schemas.microsoft.com/office/mac/drawingml/2011/main" val="0"/>
+              <ma14:wrappingTextBoxFlag xmlns:ma14="http://schemas.microsoft.com/office/mac/drawingml/2011/main" xmlns="" val="0"/>
             </a:ext>
           </a:extLst>
         </p:spPr>
@@ -11840,7 +11864,7 @@
           </a:prstGeom>
           <a:extLst>
             <a:ext uri="{C572A759-6A51-4108-AA02-DFA0A04FC94B}">
-              <ma14:wrappingTextBoxFlag xmlns="" xmlns:ma14="http://schemas.microsoft.com/office/mac/drawingml/2011/main" val="0"/>
+              <ma14:wrappingTextBoxFlag xmlns:ma14="http://schemas.microsoft.com/office/mac/drawingml/2011/main" xmlns="" val="0"/>
             </a:ext>
           </a:extLst>
         </p:spPr>
@@ -11910,7 +11934,7 @@
           </a:prstGeom>
           <a:extLst>
             <a:ext uri="{C572A759-6A51-4108-AA02-DFA0A04FC94B}">
-              <ma14:wrappingTextBoxFlag xmlns="" xmlns:ma14="http://schemas.microsoft.com/office/mac/drawingml/2011/main" val="0"/>
+              <ma14:wrappingTextBoxFlag xmlns:ma14="http://schemas.microsoft.com/office/mac/drawingml/2011/main" xmlns="" val="0"/>
             </a:ext>
           </a:extLst>
         </p:spPr>
@@ -13056,7 +13080,7 @@
           </a:prstGeom>
           <a:extLst>
             <a:ext uri="{C572A759-6A51-4108-AA02-DFA0A04FC94B}">
-              <ma14:wrappingTextBoxFlag xmlns="" xmlns:ma14="http://schemas.microsoft.com/office/mac/drawingml/2011/main" val="0"/>
+              <ma14:wrappingTextBoxFlag xmlns:ma14="http://schemas.microsoft.com/office/mac/drawingml/2011/main" xmlns="" val="0"/>
             </a:ext>
           </a:extLst>
         </p:spPr>
@@ -14774,7 +14798,7 @@
           </a:prstGeom>
           <a:extLst>
             <a:ext uri="{C572A759-6A51-4108-AA02-DFA0A04FC94B}">
-              <ma14:wrappingTextBoxFlag xmlns="" xmlns:ma14="http://schemas.microsoft.com/office/mac/drawingml/2011/main" val="0"/>
+              <ma14:wrappingTextBoxFlag xmlns:ma14="http://schemas.microsoft.com/office/mac/drawingml/2011/main" xmlns="" val="0"/>
             </a:ext>
           </a:extLst>
         </p:spPr>
@@ -14880,7 +14904,7 @@
           </a:prstGeom>
           <a:extLst>
             <a:ext uri="{C572A759-6A51-4108-AA02-DFA0A04FC94B}">
-              <ma14:wrappingTextBoxFlag xmlns="" xmlns:ma14="http://schemas.microsoft.com/office/mac/drawingml/2011/main" val="0"/>
+              <ma14:wrappingTextBoxFlag xmlns:ma14="http://schemas.microsoft.com/office/mac/drawingml/2011/main" xmlns="" val="0"/>
             </a:ext>
           </a:extLst>
         </p:spPr>
@@ -16505,7 +16529,7 @@
           </a:prstGeom>
           <a:extLst>
             <a:ext uri="{C572A759-6A51-4108-AA02-DFA0A04FC94B}">
-              <ma14:wrappingTextBoxFlag xmlns="" xmlns:ma14="http://schemas.microsoft.com/office/mac/drawingml/2011/main" val="0"/>
+              <ma14:wrappingTextBoxFlag xmlns:ma14="http://schemas.microsoft.com/office/mac/drawingml/2011/main" xmlns="" val="0"/>
             </a:ext>
           </a:extLst>
         </p:spPr>
@@ -20723,7 +20747,7 @@
           </a:prstGeom>
           <a:extLst>
             <a:ext uri="{C572A759-6A51-4108-AA02-DFA0A04FC94B}">
-              <ma14:wrappingTextBoxFlag xmlns="" xmlns:ma14="http://schemas.microsoft.com/office/mac/drawingml/2011/main" val="0"/>
+              <ma14:wrappingTextBoxFlag xmlns:ma14="http://schemas.microsoft.com/office/mac/drawingml/2011/main" xmlns="" val="0"/>
             </a:ext>
           </a:extLst>
         </p:spPr>
@@ -20931,7 +20955,7 @@
           </a:prstGeom>
           <a:extLst>
             <a:ext uri="{C572A759-6A51-4108-AA02-DFA0A04FC94B}">
-              <ma14:wrappingTextBoxFlag xmlns="" xmlns:ma14="http://schemas.microsoft.com/office/mac/drawingml/2011/main" val="0"/>
+              <ma14:wrappingTextBoxFlag xmlns:ma14="http://schemas.microsoft.com/office/mac/drawingml/2011/main" xmlns="" val="0"/>
             </a:ext>
           </a:extLst>
         </p:spPr>
@@ -24494,7 +24518,7 @@
           </a:prstGeom>
           <a:extLst>
             <a:ext uri="{C572A759-6A51-4108-AA02-DFA0A04FC94B}">
-              <ma14:wrappingTextBoxFlag xmlns="" xmlns:ma14="http://schemas.microsoft.com/office/mac/drawingml/2011/main" val="0"/>
+              <ma14:wrappingTextBoxFlag xmlns:ma14="http://schemas.microsoft.com/office/mac/drawingml/2011/main" xmlns="" val="0"/>
             </a:ext>
           </a:extLst>
         </p:spPr>
@@ -26131,7 +26155,7 @@
           </a:prstGeom>
           <a:extLst>
             <a:ext uri="{C572A759-6A51-4108-AA02-DFA0A04FC94B}">
-              <ma14:wrappingTextBoxFlag xmlns="" xmlns:ma14="http://schemas.microsoft.com/office/mac/drawingml/2011/main" val="0"/>
+              <ma14:wrappingTextBoxFlag xmlns:ma14="http://schemas.microsoft.com/office/mac/drawingml/2011/main" xmlns="" val="0"/>
             </a:ext>
           </a:extLst>
         </p:spPr>

</xml_diff>